<commit_message>
Use real wall-mounted dual-flush plates in the deck
Replace lid-button toilet art with concealed-cistern wall plates and workplace restroom photos, matching how dual flush actually looks on site.

Co-authored-by: iremalisan <iremalisan@users.noreply.github.com>
</commit_message>
<xml_diff>
--- a/sunum/Endustriyel_Tesisler_Mavi_Su_Belgesi.pptx
+++ b/sunum/Endustriyel_Tesisler_Mavi_Su_Belgesi.pptx
@@ -5359,7 +5359,7 @@
                 </a:solidFill>
                 <a:latin typeface="Calibri"/>
               </a:rPr>
-              <a:t>Tuvaletleri sayın. Tek düğmeliyse 2 kademeli rezervuar sipariş edin. Kapakta ‘8 L / 2 L’ yazsın.</a:t>
+              <a:t>Tuvaletleri gezin. Düğme kapakta değil duvardadır. Tek basışlı paneli 2 kademeli (8 L / 2 L) yapın.</a:t>
             </a:r>
           </a:p>
         </p:txBody>
@@ -6155,7 +6155,7 @@
                 </a:solidFill>
                 <a:latin typeface="Calibri"/>
               </a:rPr>
-              <a:t>Tuvalet kapısına A4 asın: küçük düğme 2 L, büyük düğme 8 L, musluğu kapat.</a:t>
+              <a:t>Klozet üstündeki duvar paneline A4 asın: küçük basış 2 L, büyük basış 8 L.</a:t>
             </a:r>
           </a:p>
         </p:txBody>
@@ -7263,7 +7263,7 @@
                 </a:solidFill>
                 <a:latin typeface="Calibri"/>
               </a:rPr>
-              <a:t>Tuvalette 2 düğmeli sifon var, üzerinde 8 L / 2 L yazıyor.</a:t>
+              <a:t>Duvarda gömme rezervuar paneli var: büyük basış 8 L, küçük 2 L.</a:t>
             </a:r>
           </a:p>
         </p:txBody>
@@ -12762,7 +12762,7 @@
                 </a:solidFill>
                 <a:latin typeface="Calibri"/>
               </a:rPr>
-              <a:t>Sifon kapağında 2 düğme olsun</a:t>
+              <a:t>Düğmeler duvardadır: gömme rezervuar paneli</a:t>
             </a:r>
           </a:p>
         </p:txBody>
@@ -12795,14 +12795,14 @@
                 </a:solidFill>
                 <a:latin typeface="Calibri"/>
               </a:rPr>
-              <a:t>Mavi belgenin 6. maddesi bunu ister: bireysel kullanımda suyu az harcayan armatür.</a:t>
+              <a:t>Kapakta düğme aramayın. Çoğu işyeri tuvaletinde çift basış, klozetin üstündeki duvar panelindedir.</a:t>
             </a:r>
           </a:p>
         </p:txBody>
       </p:sp>
       <p:pic>
         <p:nvPicPr>
-          <p:cNvPr id="8" name="Picture 7" descr="flush.jpg"/>
+          <p:cNvPr id="8" name="Picture 7" descr="flushroom.jpg"/>
           <p:cNvPicPr>
             <a:picLocks noChangeAspect="1"/>
           </p:cNvPicPr>
@@ -12816,24 +12816,48 @@
         </p:blipFill>
         <p:spPr>
           <a:xfrm>
-            <a:off x="365760" y="1371600"/>
-            <a:ext cx="5623560" cy="4892040"/>
+            <a:off x="365760" y="1353312"/>
+            <a:ext cx="5623560" cy="2331720"/>
           </a:xfrm>
           <a:prstGeom prst="rect">
             <a:avLst/>
           </a:prstGeom>
         </p:spPr>
       </p:pic>
-      <p:sp>
-        <p:nvSpPr>
-          <p:cNvPr id="9" name="Rounded Rectangle 8"/>
-          <p:cNvSpPr/>
-          <p:nvPr/>
-        </p:nvSpPr>
-        <p:spPr>
-          <a:xfrm>
-            <a:off x="6208776" y="1417320"/>
-            <a:ext cx="5623560" cy="2240280"/>
+      <p:pic>
+        <p:nvPicPr>
+          <p:cNvPr id="9" name="Picture 8" descr="flushplate.jpg"/>
+          <p:cNvPicPr>
+            <a:picLocks noChangeAspect="1"/>
+          </p:cNvPicPr>
+          <p:nvPr/>
+        </p:nvPicPr>
+        <p:blipFill>
+          <a:blip r:embed="rId3"/>
+          <a:stretch>
+            <a:fillRect/>
+          </a:stretch>
+        </p:blipFill>
+        <p:spPr>
+          <a:xfrm>
+            <a:off x="365760" y="3794760"/>
+            <a:ext cx="5623560" cy="2468880"/>
+          </a:xfrm>
+          <a:prstGeom prst="rect">
+            <a:avLst/>
+          </a:prstGeom>
+        </p:spPr>
+      </p:pic>
+      <p:sp>
+        <p:nvSpPr>
+          <p:cNvPr id="10" name="Rounded Rectangle 9"/>
+          <p:cNvSpPr/>
+          <p:nvPr/>
+        </p:nvSpPr>
+        <p:spPr>
+          <a:xfrm>
+            <a:off x="6208776" y="1399032"/>
+            <a:ext cx="5623560" cy="2286000"/>
           </a:xfrm>
           <a:prstGeom prst="roundRect">
             <a:avLst>
@@ -12871,14 +12895,14 @@
       </p:sp>
       <p:sp>
         <p:nvSpPr>
-          <p:cNvPr id="10" name="Rounded Rectangle 9"/>
-          <p:cNvSpPr/>
-          <p:nvPr/>
-        </p:nvSpPr>
-        <p:spPr>
-          <a:xfrm>
-            <a:off x="6172200" y="1371600"/>
-            <a:ext cx="5623560" cy="2240280"/>
+          <p:cNvPr id="11" name="Rounded Rectangle 10"/>
+          <p:cNvSpPr/>
+          <p:nvPr/>
+        </p:nvSpPr>
+        <p:spPr>
+          <a:xfrm>
+            <a:off x="6172200" y="1353312"/>
+            <a:ext cx="5623560" cy="2286000"/>
           </a:xfrm>
           <a:prstGeom prst="roundRect">
             <a:avLst>
@@ -12916,13 +12940,13 @@
       </p:sp>
       <p:sp>
         <p:nvSpPr>
-          <p:cNvPr id="11" name="Oval 10"/>
-          <p:cNvSpPr/>
-          <p:nvPr/>
-        </p:nvSpPr>
-        <p:spPr>
-          <a:xfrm>
-            <a:off x="6355080" y="1572768"/>
+          <p:cNvPr id="12" name="Oval 11"/>
+          <p:cNvSpPr/>
+          <p:nvPr/>
+        </p:nvSpPr>
+        <p:spPr>
+          <a:xfrm>
+            <a:off x="6355080" y="1554480"/>
             <a:ext cx="640080" cy="640080"/>
           </a:xfrm>
           <a:prstGeom prst="ellipse">
@@ -12959,13 +12983,13 @@
       </p:sp>
       <p:sp>
         <p:nvSpPr>
-          <p:cNvPr id="12" name="TextBox 11"/>
+          <p:cNvPr id="13" name="TextBox 12"/>
           <p:cNvSpPr txBox="1"/>
           <p:nvPr/>
         </p:nvSpPr>
         <p:spPr>
           <a:xfrm>
-            <a:off x="6355080" y="1719072"/>
+            <a:off x="6355080" y="1700784"/>
             <a:ext cx="640080" cy="384048"/>
           </a:xfrm>
           <a:prstGeom prst="rect">
@@ -12992,13 +13016,13 @@
       </p:sp>
       <p:sp>
         <p:nvSpPr>
-          <p:cNvPr id="13" name="TextBox 12"/>
+          <p:cNvPr id="14" name="TextBox 13"/>
           <p:cNvSpPr txBox="1"/>
           <p:nvPr/>
         </p:nvSpPr>
         <p:spPr>
           <a:xfrm>
-            <a:off x="7132320" y="1572768"/>
+            <a:off x="7132320" y="1554480"/>
             <a:ext cx="4434840" cy="365760"/>
           </a:xfrm>
           <a:prstGeom prst="rect">
@@ -13018,21 +13042,21 @@
                 </a:solidFill>
                 <a:latin typeface="Calibri"/>
               </a:rPr>
-              <a:t>Büyük düğme  =  tam sifon</a:t>
-            </a:r>
-          </a:p>
-        </p:txBody>
-      </p:sp>
-      <p:sp>
-        <p:nvSpPr>
-          <p:cNvPr id="14" name="TextBox 13"/>
+              <a:t>Büyük basış  =  tam sifon</a:t>
+            </a:r>
+          </a:p>
+        </p:txBody>
+      </p:sp>
+      <p:sp>
+        <p:nvSpPr>
+          <p:cNvPr id="15" name="TextBox 14"/>
           <p:cNvSpPr txBox="1"/>
           <p:nvPr/>
         </p:nvSpPr>
         <p:spPr>
           <a:xfrm>
-            <a:off x="7132320" y="2011680"/>
-            <a:ext cx="4434840" cy="1325880"/>
+            <a:off x="7132320" y="1993392"/>
+            <a:ext cx="4434840" cy="1417320"/>
           </a:xfrm>
           <a:prstGeom prst="rect">
             <a:avLst/>
@@ -13051,14 +13075,14 @@
                 </a:solidFill>
                 <a:latin typeface="Calibri"/>
               </a:rPr>
-              <a:t>Katı atık için. Eski tek düğmeli rezervuar her seferinde 8–9 litre boşaltır. Bunu yalnızca gerektiğinde kullanın.</a:t>
-            </a:r>
-          </a:p>
-        </p:txBody>
-      </p:sp>
-      <p:sp>
-        <p:nvSpPr>
-          <p:cNvPr id="15" name="Rounded Rectangle 14"/>
+              <a:t>Duvar panelindeki büyük düğme. Katı atık için. Eski tek basışlı rezervuar her seferinde 8–9 litre boşaltır; bunu yalnızca gerektiğinde kullanın.</a:t>
+            </a:r>
+          </a:p>
+        </p:txBody>
+      </p:sp>
+      <p:sp>
+        <p:nvSpPr>
+          <p:cNvPr id="16" name="Rounded Rectangle 15"/>
           <p:cNvSpPr/>
           <p:nvPr/>
         </p:nvSpPr>
@@ -13103,7 +13127,7 @@
       </p:sp>
       <p:sp>
         <p:nvSpPr>
-          <p:cNvPr id="16" name="Rounded Rectangle 15"/>
+          <p:cNvPr id="17" name="Rounded Rectangle 16"/>
           <p:cNvSpPr/>
           <p:nvPr/>
         </p:nvSpPr>
@@ -13148,7 +13172,7 @@
       </p:sp>
       <p:sp>
         <p:nvSpPr>
-          <p:cNvPr id="17" name="Oval 16"/>
+          <p:cNvPr id="18" name="Oval 17"/>
           <p:cNvSpPr/>
           <p:nvPr/>
         </p:nvSpPr>
@@ -13191,7 +13215,7 @@
       </p:sp>
       <p:sp>
         <p:nvSpPr>
-          <p:cNvPr id="18" name="TextBox 17"/>
+          <p:cNvPr id="19" name="TextBox 18"/>
           <p:cNvSpPr txBox="1"/>
           <p:nvPr/>
         </p:nvSpPr>
@@ -13224,7 +13248,7 @@
       </p:sp>
       <p:sp>
         <p:nvSpPr>
-          <p:cNvPr id="19" name="TextBox 18"/>
+          <p:cNvPr id="20" name="TextBox 19"/>
           <p:cNvSpPr txBox="1"/>
           <p:nvPr/>
         </p:nvSpPr>
@@ -13250,14 +13274,14 @@
                 </a:solidFill>
                 <a:latin typeface="Calibri"/>
               </a:rPr>
-              <a:t>Küçük düğme  =  yarım sifon</a:t>
-            </a:r>
-          </a:p>
-        </p:txBody>
-      </p:sp>
-      <p:sp>
-        <p:nvSpPr>
-          <p:cNvPr id="20" name="TextBox 19"/>
+              <a:t>Küçük basış  =  yarım sifon</a:t>
+            </a:r>
+          </a:p>
+        </p:txBody>
+      </p:sp>
+      <p:sp>
+        <p:nvSpPr>
+          <p:cNvPr id="21" name="TextBox 20"/>
           <p:cNvSpPr txBox="1"/>
           <p:nvPr/>
         </p:nvSpPr>
@@ -13283,14 +13307,14 @@
                 </a:solidFill>
                 <a:latin typeface="Calibri"/>
               </a:rPr>
-              <a:t>Sıvı atık için. 2–3 litre yeter. 40 çalışan günde 4 kez basarsa: eski sistem ~1.280 L, yeni sistem ~480 L. Fark günde 800 litre.</a:t>
-            </a:r>
-          </a:p>
-        </p:txBody>
-      </p:sp>
-      <p:sp>
-        <p:nvSpPr>
-          <p:cNvPr id="21" name="TextBox 20"/>
+              <a:t>Paneldeki küçük düğme. Sıvı atık için 2–3 litre yeter. 40 çalışan günde 4 kez basarsa: eski sistem ~1.280 L, yeni sistem ~480 L. Fark günde 800 litre.</a:t>
+            </a:r>
+          </a:p>
+        </p:txBody>
+      </p:sp>
+      <p:sp>
+        <p:nvSpPr>
+          <p:cNvPr id="22" name="TextBox 21"/>
           <p:cNvSpPr txBox="1"/>
           <p:nvPr/>
         </p:nvSpPr>
@@ -13323,7 +13347,7 @@
       </p:sp>
       <p:sp>
         <p:nvSpPr>
-          <p:cNvPr id="22" name="TextBox 21"/>
+          <p:cNvPr id="23" name="TextBox 22"/>
           <p:cNvSpPr txBox="1"/>
           <p:nvPr/>
         </p:nvSpPr>
@@ -13790,7 +13814,7 @@
                 </a:solidFill>
                 <a:latin typeface="Calibri"/>
               </a:rPr>
-              <a:t>Fotoselli (fotocell) musluk</a:t>
+              <a:t>Fotoselli veya zaman ayarlı musluk</a:t>
             </a:r>
           </a:p>
         </p:txBody>
@@ -13823,7 +13847,7 @@
                 </a:solidFill>
                 <a:latin typeface="Calibri"/>
               </a:rPr>
-              <a:t>Sensör eli görünce açılır, el gidince kapanır. ‘Açık unutulan musluk’ biter. Lavabo başında 10–12 L/dk yerine 5–6 L/dk.</a:t>
+              <a:t>Eli çekince / süre dolunca su kesilir. ‘Açık unutulan musluk’ biter. Lavabo başında 10–12 L/dk yerine 5–6 L/dk.</a:t>
             </a:r>
           </a:p>
         </p:txBody>
@@ -15494,7 +15518,7 @@
                 </a:solidFill>
                 <a:latin typeface="Calibri"/>
               </a:rPr>
-              <a:t>Tuvalet kapısına afiş</a:t>
+              <a:t>Tuvalet duvarına afiş</a:t>
             </a:r>
           </a:p>
         </p:txBody>
@@ -15527,7 +15551,7 @@
                 </a:solidFill>
                 <a:latin typeface="Calibri"/>
               </a:rPr>
-              <a:t>‘Küçük düğme 2 L — büyük düğme 8 L’. Yemekhane ekranında aynı mesaj. Fotoğrafını çekin, sisteme yükleyin.</a:t>
+              <a:t>‘Küçük basış 2 L — büyük basış 8 L’ (duvardaki panel). Fotoğrafını çekin, sisteme yükleyin.</a:t>
             </a:r>
           </a:p>
         </p:txBody>
@@ -16630,7 +16654,7 @@
                 </a:solidFill>
                 <a:latin typeface="Calibri"/>
               </a:rPr>
-              <a:t>Bu yıl: tüm tuvaletlere 2 kademeli sifon.
+              <a:t>Bu yıl: gömme rezervuar panellerini 2 kademeli yapın.
 Bu yıl: 20 lavaboya perlatör + 8’ine fotosel.
 Bu yıl: hortum tabancası.
 3 yılda: yağmur deposu.

</xml_diff>